<commit_message>
docs: align workflow deck with protocol
</commit_message>
<xml_diff>
--- a/docs/agentic-workflow.pptx
+++ b/docs/agentic-workflow.pptx
@@ -3212,9 +3212,6 @@
               <a:t>Agentic Workflow</a:t>
             </a:r>
           </a:p>
-          <a:p>
-            <a:pPr algn="l"/>
-          </a:p>
         </p:txBody>
       </p:sp>
       <p:sp>
@@ -3588,7 +3585,7 @@
                   <a:srgbClr val="93C5FD"/>
                 </a:solidFill>
               </a:rPr>
-              <a:t>Design</a:t>
+              <a:t>UX+Design</a:t>
             </a:r>
           </a:p>
           <a:p>
@@ -3599,7 +3596,7 @@
                   <a:srgbClr val="5A8ABD"/>
                 </a:solidFill>
               </a:rPr>
-              <a:t>UX Agent</a:t>
+              <a:t>Orchestrator</a:t>
             </a:r>
           </a:p>
         </p:txBody>
@@ -3994,7 +3991,7 @@
                   <a:srgbClr val="B07CC0"/>
                 </a:solidFill>
               </a:rPr>
-              <a:t>GitHub UI</a:t>
+              <a:t>PO-only</a:t>
             </a:r>
           </a:p>
         </p:txBody>
@@ -5428,7 +5425,7 @@
                   <a:srgbClr val="8B949E"/>
                 </a:solidFill>
               </a:rPr>
-              <a:t>UX Agent designs screens in Figma; Design QA Agent validates fidelity.</a:t>
+              <a:t>Orchestrator executes UX+Design in Gate 3A; Design QA Agent validates fidelity in Gate 3B.</a:t>
             </a:r>
           </a:p>
         </p:txBody>
@@ -5994,7 +5991,7 @@
                   <a:srgbClr val="8B949E"/>
                 </a:solidFill>
               </a:rPr>
-              <a:t>Orchestrator confirms all evidence; Product Owner merges via GitHub UI.</a:t>
+              <a:t>Orchestrator confirms all evidence; Product Owner merges the PR.</a:t>
             </a:r>
           </a:p>
         </p:txBody>

</xml_diff>

<commit_message>
docs: align workflow artifact terminology
</commit_message>
<xml_diff>
--- a/docs/agentic-workflow.pptx
+++ b/docs/agentic-workflow.pptx
@@ -3900,12 +3900,12 @@
           <a:p>
             <a:pPr algn="ctr"/>
             <a:r>
-              <a:rPr sz="1100" b="0">
+              <a:rPr sz="1000" b="0">
                 <a:solidFill>
                   <a:srgbClr val="93C5FD"/>
                 </a:solidFill>
               </a:rPr>
-              <a:t>Merge Ready</a:t>
+              <a:t>Merge Readiness</a:t>
             </a:r>
           </a:p>
           <a:p>
@@ -5958,7 +5958,7 @@
                   <a:srgbClr val="E6EDF3"/>
                 </a:solidFill>
               </a:rPr>
-              <a:t>Merge Ready</a:t>
+              <a:t>Merge Readiness</a:t>
             </a:r>
           </a:p>
         </p:txBody>

</xml_diff>

<commit_message>
docs: align merge policy wording
</commit_message>
<xml_diff>
--- a/docs/agentic-workflow.pptx
+++ b/docs/agentic-workflow.pptx
@@ -3969,18 +3969,18 @@
                   <a:srgbClr val="FAE8FD"/>
                 </a:solidFill>
               </a:rPr>
-              <a:t>👤 PO</a:t>
-            </a:r>
-          </a:p>
-          <a:p>
-            <a:pPr algn="ctr"/>
-            <a:r>
-              <a:rPr sz="1000" b="0">
+              <a:t>Merge</a:t>
+            </a:r>
+          </a:p>
+          <a:p>
+            <a:pPr algn="ctr"/>
+            <a:r>
+              <a:rPr sz="800" b="0">
                 <a:solidFill>
                   <a:srgbClr val="E0A8E8"/>
                 </a:solidFill>
               </a:rPr>
-              <a:t>Merges PR</a:t>
+              <a:t>PO: default branch</a:t>
             </a:r>
           </a:p>
           <a:p>
@@ -3991,7 +3991,7 @@
                   <a:srgbClr val="B07CC0"/>
                 </a:solidFill>
               </a:rPr>
-              <a:t>PO-only</a:t>
+              <a:t>Orch: slice/*</a:t>
             </a:r>
           </a:p>
         </p:txBody>
@@ -5991,7 +5991,7 @@
                   <a:srgbClr val="8B949E"/>
                 </a:solidFill>
               </a:rPr>
-              <a:t>Orchestrator confirms all evidence; Product Owner merges the PR.</a:t>
+              <a:t>Orchestrator confirms all evidence; Product Owner merges default-branch PRs, while the Orchestrator may merge qualifying slice/* integration-branch PRs under the documented exception.</a:t>
             </a:r>
           </a:p>
         </p:txBody>

</xml_diff>